<commit_message>
Docs + deck: reflect native apps now build free in CI and are downloadable
- README/CLAUDE/mobile docs: Android APK is built in GitHub Actions and live on /app;
  iOS produces a free sideloadable .ipa via CI. Replaced the stale "scaffolded / not
  built / hardware-blocked" wording. Roadmap trimmed to real remaining items.
- presentation.pptx: added "Native Android app + iOS sideload" to the CONNECT slide.

Co-Authored-By: Claude Opus 4.8 <noreply@anthropic.com>
</commit_message>
<xml_diff>
--- a/fitness_ai_agents_presentation.pptx
+++ b/fitness_ai_agents_presentation.pptx
@@ -6016,6 +6016,18 @@
 Apple Health · Garmin
 .fit / .tcx / .gpx files
 Manual log + GPS tracker</a:t>
+            </a:r>
+          </a:p>
+          <a:p>
+            <a:pPr algn="l"/>
+            <a:r>
+              <a:rPr sz="1600" b="0" i="0">
+                <a:solidFill>
+                  <a:srgbClr val="B0CEE6"/>
+                </a:solidFill>
+                <a:latin typeface="Calibri"/>
+              </a:rPr>
+              <a:t>Native Android app + iOS sideload</a:t>
             </a:r>
           </a:p>
         </p:txBody>

</xml_diff>

<commit_message>
Deck: update speaker notes for downloadable native apps (slides 3, 7, 8)
Co-Authored-By: Claude Opus 4.8 <noreply@anthropic.com>
</commit_message>
<xml_diff>
--- a/fitness_ai_agents_presentation.pptx
+++ b/fitness_ai_agents_presentation.pptx
@@ -754,6 +754,11 @@
               <a:t>That's the full loop — from raw sensor data to a decision you can act on today." </a:t>
             </a:r>
           </a:p>
+          <a:p>
+            <a:r>
+              <a:t>[ADD — phone as a tracker] "And if you do not have a watch at all, that is fine too. There are native Android and iOS apps you can install straight from the site that turn your phone itself into the tracker. No app store needed."</a:t>
+            </a:r>
+          </a:p>
         </p:txBody>
       </p:sp>
       <p:sp>
@@ -1172,6 +1177,11 @@
               <a:t>And this is not a prototype — it's live, right now. You can go to fitness-ai-agents.vercel.app, click 'Load Sample Data', and see the full dashboard with charts, heatmaps, AI analysis results, and a readiness score populated in about 90 seconds." </a:t>
             </a:r>
           </a:p>
+          <a:p>
+            <a:r>
+              <a:t>[ADD] "And the reach is not just the web app. The native Android and iOS apps build automatically in the cloud and publish straight to the site, so anyone can download and install them for free."</a:t>
+            </a:r>
+          </a:p>
         </p:txBody>
       </p:sp>
       <p:sp>
@@ -1270,6 +1280,11 @@
           <a:p>
             <a:r>
               <a:t>Then stop. Let them ask.</a:t>
+            </a:r>
+          </a:p>
+          <a:p>
+            <a:r>
+              <a:t>[ADD before final line] "It runs in any browser, installs as an app on any phone or desktop, and has downloadable native Android and iOS builds."</a:t>
             </a:r>
           </a:p>
         </p:txBody>

</xml_diff>